<commit_message>
Detail security and compliance features in product introduction
Enhance PRODUCT_INTRODUCTION_EN.html and PRODUCT_INTRODUCTION_EN.md to include comprehensive details on KMS, mTLS, API Key Management, WireGuard VPN, audit logging, and compliance certifications (SOC 2, PCI DSS, GDPR).

Replit-Commit-Author: Agent
Replit-Commit-Session-Id: f5874770-ab78-47d7-a201-29323951684a
Replit-Commit-Checkpoint-Type: full_checkpoint
Replit-Commit-Screenshot-Url: https://storage.googleapis.com/screenshot-production-us-central1/c0c817cd-9663-4b96-9a33-086737bed5dc/f5874770-ab78-47d7-a201-29323951684a/b5tUY3j
</commit_message>
<xml_diff>
--- a/HashInsight_Product_Introduction_EN.pptx
+++ b/HashInsight_Product_Introduction_EN.pptx
@@ -3297,9 +3297,9 @@
           <a:p>
             <a:pPr>
               <a:spcBef>
-                <a:spcPts val="600"/>
-              </a:spcBef>
-              <a:defRPr sz="1600"/>
+                <a:spcPts val="400"/>
+              </a:spcBef>
+              <a:defRPr sz="1400"/>
             </a:pPr>
             <a:r>
               <a:t>Target Users</a:t>
@@ -3308,28 +3308,28 @@
           <a:p>
             <a:pPr>
               <a:spcBef>
-                <a:spcPts val="600"/>
-              </a:spcBef>
-              <a:defRPr sz="1600"/>
-            </a:pPr>
-            <a:r>
-              <a:t>  Mining farm operators, hosting providers, large-scale miners, institutional investors</a:t>
-            </a:r>
-          </a:p>
-          <a:p>
-            <a:pPr>
-              <a:spcBef>
-                <a:spcPts val="600"/>
-              </a:spcBef>
-              <a:defRPr sz="1600"/>
-            </a:pPr>
-          </a:p>
-          <a:p>
-            <a:pPr>
-              <a:spcBef>
-                <a:spcPts val="600"/>
-              </a:spcBef>
-              <a:defRPr sz="1600"/>
+                <a:spcPts val="400"/>
+              </a:spcBef>
+              <a:defRPr sz="1400"/>
+            </a:pPr>
+            <a:r>
+              <a:t>  Mining farms, hosting providers, large miners, institutional investors</a:t>
+            </a:r>
+          </a:p>
+          <a:p>
+            <a:pPr>
+              <a:spcBef>
+                <a:spcPts val="400"/>
+              </a:spcBef>
+              <a:defRPr sz="1400"/>
+            </a:pPr>
+          </a:p>
+          <a:p>
+            <a:pPr>
+              <a:spcBef>
+                <a:spcPts val="400"/>
+              </a:spcBef>
+              <a:defRPr sz="1400"/>
             </a:pPr>
             <a:r>
               <a:t>Core Value Proposition</a:t>
@@ -3338,31 +3338,20 @@
           <a:p>
             <a:pPr>
               <a:spcBef>
-                <a:spcPts val="600"/>
-              </a:spcBef>
-              <a:defRPr sz="1600"/>
-            </a:pPr>
-            <a:r>
-              <a:t>  Data-driven mining decisions</a:t>
-            </a:r>
-          </a:p>
-          <a:p>
-            <a:pPr>
-              <a:spcBef>
-                <a:spcPts val="600"/>
-              </a:spcBef>
-              <a:defRPr sz="1600"/>
-            </a:pPr>
-            <a:r>
-              <a:t>  Professional-grade financial management</a:t>
-            </a:r>
-          </a:p>
-          <a:p>
-            <a:pPr>
-              <a:spcBef>
-                <a:spcPts val="600"/>
-              </a:spcBef>
-              <a:defRPr sz="1600"/>
+                <a:spcPts val="400"/>
+              </a:spcBef>
+              <a:defRPr sz="1400"/>
+            </a:pPr>
+            <a:r>
+              <a:t>  Data-driven decisions, professional financial management</a:t>
+            </a:r>
+          </a:p>
+          <a:p>
+            <a:pPr>
+              <a:spcBef>
+                <a:spcPts val="400"/>
+              </a:spcBef>
+              <a:defRPr sz="1400"/>
             </a:pPr>
             <a:r>
               <a:t>  Transparent customer service</a:t>
@@ -3371,17 +3360,17 @@
           <a:p>
             <a:pPr>
               <a:spcBef>
-                <a:spcPts val="600"/>
-              </a:spcBef>
-              <a:defRPr sz="1600"/>
-            </a:pPr>
-          </a:p>
-          <a:p>
-            <a:pPr>
-              <a:spcBef>
-                <a:spcPts val="600"/>
-              </a:spcBef>
-              <a:defRPr sz="1600"/>
+                <a:spcPts val="400"/>
+              </a:spcBef>
+              <a:defRPr sz="1400"/>
+            </a:pPr>
+          </a:p>
+          <a:p>
+            <a:pPr>
+              <a:spcBef>
+                <a:spcPts val="400"/>
+              </a:spcBef>
+              <a:defRPr sz="1400"/>
             </a:pPr>
             <a:r>
               <a:t>Technical Guarantees</a:t>
@@ -3390,12 +3379,12 @@
           <a:p>
             <a:pPr>
               <a:spcBef>
-                <a:spcPts val="600"/>
-              </a:spcBef>
-              <a:defRPr sz="1600"/>
-            </a:pPr>
-            <a:r>
-              <a:t>  Enterprise-grade security, 99.95% SLA, 9.8x performance optimization</a:t>
+                <a:spcPts val="400"/>
+              </a:spcBef>
+              <a:defRPr sz="1400"/>
+            </a:pPr>
+            <a:r>
+              <a:t>  99.95% SLA, 9.8x performance, enterprise-grade security</a:t>
             </a:r>
           </a:p>
         </p:txBody>
@@ -3523,176 +3512,88 @@
           <a:p>
             <a:pPr>
               <a:spcBef>
-                <a:spcPts val="600"/>
-              </a:spcBef>
-              <a:defRPr sz="1600"/>
-            </a:pPr>
-            <a:r>
-              <a:t>1. Intelligent Mining Calculator</a:t>
-            </a:r>
-          </a:p>
-          <a:p>
-            <a:pPr>
-              <a:spcBef>
-                <a:spcPts val="600"/>
-              </a:spcBef>
-              <a:defRPr sz="1600"/>
-            </a:pPr>
-            <a:r>
-              <a:t>   • Supports 17+ miner models, dual-algorithm validation</a:t>
-            </a:r>
-          </a:p>
-          <a:p>
-            <a:pPr>
-              <a:spcBef>
-                <a:spcPts val="600"/>
-              </a:spcBef>
-              <a:defRPr sz="1600"/>
-            </a:pPr>
-            <a:r>
-              <a:t>   • Batch processing 5000+ miners, power curtailment analysis</a:t>
-            </a:r>
-          </a:p>
-          <a:p>
-            <a:pPr>
-              <a:spcBef>
-                <a:spcPts val="600"/>
-              </a:spcBef>
-              <a:defRPr sz="1600"/>
-            </a:pPr>
-          </a:p>
-          <a:p>
-            <a:pPr>
-              <a:spcBef>
-                <a:spcPts val="600"/>
-              </a:spcBef>
-              <a:defRPr sz="1600"/>
-            </a:pPr>
-            <a:r>
-              <a:t>2. Professional Technical Analysis Platform</a:t>
-            </a:r>
-          </a:p>
-          <a:p>
-            <a:pPr>
-              <a:spcBef>
-                <a:spcPts val="600"/>
-              </a:spcBef>
-              <a:defRPr sz="1600"/>
-            </a:pPr>
-            <a:r>
-              <a:t>   • 10 signal modules: RSI/MACD/Bollinger Bands</a:t>
-            </a:r>
-          </a:p>
-          <a:p>
-            <a:pPr>
-              <a:spcBef>
-                <a:spcPts val="600"/>
-              </a:spcBef>
-              <a:defRPr sz="1600"/>
-            </a:pPr>
-            <a:r>
-              <a:t>   • Intelligent market sentiment scoring</a:t>
-            </a:r>
-          </a:p>
-          <a:p>
-            <a:pPr>
-              <a:spcBef>
-                <a:spcPts val="600"/>
-              </a:spcBef>
-              <a:defRPr sz="1600"/>
-            </a:pPr>
-          </a:p>
-          <a:p>
-            <a:pPr>
-              <a:spcBef>
-                <a:spcPts val="600"/>
-              </a:spcBef>
-              <a:defRPr sz="1600"/>
-            </a:pPr>
-            <a:r>
-              <a:t>3. Treasury Management</a:t>
-            </a:r>
-          </a:p>
-          <a:p>
-            <a:pPr>
-              <a:spcBef>
-                <a:spcPts val="600"/>
-              </a:spcBef>
-              <a:defRPr sz="1600"/>
-            </a:pPr>
-            <a:r>
-              <a:t>   • BTC inventory tracking, selling strategy templates</a:t>
-            </a:r>
-          </a:p>
-          <a:p>
-            <a:pPr>
-              <a:spcBef>
-                <a:spcPts val="600"/>
-              </a:spcBef>
-              <a:defRPr sz="1600"/>
-            </a:pPr>
-            <a:r>
-              <a:t>   • Order execution optimization, backtesting engine</a:t>
-            </a:r>
-          </a:p>
-          <a:p>
-            <a:pPr>
-              <a:spcBef>
-                <a:spcPts val="600"/>
-              </a:spcBef>
-              <a:defRPr sz="1600"/>
-            </a:pPr>
-          </a:p>
-          <a:p>
-            <a:pPr>
-              <a:spcBef>
-                <a:spcPts val="600"/>
-              </a:spcBef>
-              <a:defRPr sz="1600"/>
-            </a:pPr>
-            <a:r>
-              <a:t>4. CRM Customer Management</a:t>
-            </a:r>
-          </a:p>
-          <a:p>
-            <a:pPr>
-              <a:spcBef>
-                <a:spcPts val="600"/>
-              </a:spcBef>
-              <a:defRPr sz="1600"/>
-            </a:pPr>
-            <a:r>
-              <a:t>   • Customer lifecycle management, automated commission calculation</a:t>
-            </a:r>
-          </a:p>
-          <a:p>
-            <a:pPr>
-              <a:spcBef>
-                <a:spcPts val="600"/>
-              </a:spcBef>
-              <a:defRPr sz="1600"/>
-            </a:pPr>
-          </a:p>
-          <a:p>
-            <a:pPr>
-              <a:spcBef>
-                <a:spcPts val="600"/>
-              </a:spcBef>
-              <a:defRPr sz="1600"/>
-            </a:pPr>
-            <a:r>
-              <a:t>5. Enterprise-Grade Security</a:t>
-            </a:r>
-          </a:p>
-          <a:p>
-            <a:pPr>
-              <a:spcBef>
-                <a:spcPts val="600"/>
-              </a:spcBef>
-              <a:defRPr sz="1600"/>
-            </a:pPr>
-            <a:r>
-              <a:t>   • KMS encryption, mTLS authentication, SOC 2 compliance</a:t>
+                <a:spcPts val="400"/>
+              </a:spcBef>
+              <a:defRPr sz="1400"/>
+            </a:pPr>
+            <a:r>
+              <a:t>1. Intelligent Mining Calculator - 17+ models, dual validation</a:t>
+            </a:r>
+          </a:p>
+          <a:p>
+            <a:pPr>
+              <a:spcBef>
+                <a:spcPts val="400"/>
+              </a:spcBef>
+              <a:defRPr sz="1400"/>
+            </a:pPr>
+          </a:p>
+          <a:p>
+            <a:pPr>
+              <a:spcBef>
+                <a:spcPts val="400"/>
+              </a:spcBef>
+              <a:defRPr sz="1400"/>
+            </a:pPr>
+            <a:r>
+              <a:t>2. Technical Analysis Platform - 10 signal modules</a:t>
+            </a:r>
+          </a:p>
+          <a:p>
+            <a:pPr>
+              <a:spcBef>
+                <a:spcPts val="400"/>
+              </a:spcBef>
+              <a:defRPr sz="1400"/>
+            </a:pPr>
+          </a:p>
+          <a:p>
+            <a:pPr>
+              <a:spcBef>
+                <a:spcPts val="400"/>
+              </a:spcBef>
+              <a:defRPr sz="1400"/>
+            </a:pPr>
+            <a:r>
+              <a:t>3. Treasury Management - BTC inventory, selling strategies</a:t>
+            </a:r>
+          </a:p>
+          <a:p>
+            <a:pPr>
+              <a:spcBef>
+                <a:spcPts val="400"/>
+              </a:spcBef>
+              <a:defRPr sz="1400"/>
+            </a:pPr>
+          </a:p>
+          <a:p>
+            <a:pPr>
+              <a:spcBef>
+                <a:spcPts val="400"/>
+              </a:spcBef>
+              <a:defRPr sz="1400"/>
+            </a:pPr>
+            <a:r>
+              <a:t>4. CRM Customer Management - Full lifecycle tracking</a:t>
+            </a:r>
+          </a:p>
+          <a:p>
+            <a:pPr>
+              <a:spcBef>
+                <a:spcPts val="400"/>
+              </a:spcBef>
+              <a:defRPr sz="1400"/>
+            </a:pPr>
+          </a:p>
+          <a:p>
+            <a:pPr>
+              <a:spcBef>
+                <a:spcPts val="400"/>
+              </a:spcBef>
+              <a:defRPr sz="1400"/>
+            </a:pPr>
+            <a:r>
+              <a:t>5. Enterprise Security - KMS, mTLS, WireGuard VPN, audit logging</a:t>
             </a:r>
           </a:p>
         </p:txBody>
@@ -3706,6 +3607,292 @@
 </file>
 
 <file path=ppt/slides/slide4.xml><?xml version="1.0" encoding="utf-8"?>
+<p:sld xmlns:a="http://schemas.openxmlformats.org/drawingml/2006/main" xmlns:p="http://schemas.openxmlformats.org/presentationml/2006/main" xmlns:r="http://schemas.openxmlformats.org/officeDocument/2006/relationships">
+  <p:cSld>
+    <p:spTree>
+      <p:nvGrpSpPr>
+        <p:cNvPr id="1" name=""/>
+        <p:cNvGrpSpPr/>
+        <p:nvPr/>
+      </p:nvGrpSpPr>
+      <p:grpSpPr/>
+      <p:sp>
+        <p:nvSpPr>
+          <p:cNvPr id="2" name="TextBox 1"/>
+          <p:cNvSpPr txBox="1"/>
+          <p:nvPr/>
+        </p:nvSpPr>
+        <p:spPr>
+          <a:xfrm>
+            <a:off x="457200" y="457200"/>
+            <a:ext cx="8229600" cy="731520"/>
+          </a:xfrm>
+          <a:prstGeom prst="rect">
+            <a:avLst/>
+          </a:prstGeom>
+          <a:noFill/>
+        </p:spPr>
+        <p:txBody>
+          <a:bodyPr wrap="none">
+            <a:spAutoFit/>
+          </a:bodyPr>
+          <a:lstStyle/>
+          <a:p>
+            <a:pPr>
+              <a:defRPr sz="3600" b="1">
+                <a:solidFill>
+                  <a:srgbClr val="2C3E50"/>
+                </a:solidFill>
+              </a:defRPr>
+            </a:pPr>
+            <a:r>
+              <a:t>Enterprise Security &amp; Compliance</a:t>
+            </a:r>
+          </a:p>
+        </p:txBody>
+      </p:sp>
+      <p:sp>
+        <p:nvSpPr>
+          <p:cNvPr id="3" name="Rectangle 2"/>
+          <p:cNvSpPr/>
+          <p:nvPr/>
+        </p:nvSpPr>
+        <p:spPr>
+          <a:xfrm>
+            <a:off x="457200" y="1143000"/>
+            <a:ext cx="8229600" cy="45720"/>
+          </a:xfrm>
+          <a:prstGeom prst="rect">
+            <a:avLst/>
+          </a:prstGeom>
+          <a:solidFill>
+            <a:srgbClr val="F39C12"/>
+          </a:solidFill>
+          <a:ln>
+            <a:solidFill>
+              <a:srgbClr val="F39C12"/>
+            </a:solidFill>
+          </a:ln>
+        </p:spPr>
+        <p:style>
+          <a:lnRef idx="1">
+            <a:schemeClr val="accent1"/>
+          </a:lnRef>
+          <a:fillRef idx="3">
+            <a:schemeClr val="accent1"/>
+          </a:fillRef>
+          <a:effectRef idx="2">
+            <a:schemeClr val="accent1"/>
+          </a:effectRef>
+          <a:fontRef idx="minor">
+            <a:schemeClr val="lt1"/>
+          </a:fontRef>
+        </p:style>
+        <p:txBody>
+          <a:bodyPr rtlCol="0" anchor="ctr"/>
+          <a:lstStyle/>
+          <a:p>
+            <a:pPr algn="ctr"/>
+          </a:p>
+        </p:txBody>
+      </p:sp>
+      <p:sp>
+        <p:nvSpPr>
+          <p:cNvPr id="4" name="TextBox 3"/>
+          <p:cNvSpPr txBox="1"/>
+          <p:nvPr/>
+        </p:nvSpPr>
+        <p:spPr>
+          <a:xfrm>
+            <a:off x="457200" y="1463040"/>
+            <a:ext cx="8229600" cy="4114800"/>
+          </a:xfrm>
+          <a:prstGeom prst="rect">
+            <a:avLst/>
+          </a:prstGeom>
+          <a:noFill/>
+        </p:spPr>
+        <p:txBody>
+          <a:bodyPr wrap="square">
+            <a:spAutoFit/>
+          </a:bodyPr>
+          <a:lstStyle/>
+          <a:p/>
+          <a:p>
+            <a:pPr>
+              <a:spcBef>
+                <a:spcPts val="400"/>
+              </a:spcBef>
+              <a:defRPr sz="1400"/>
+            </a:pPr>
+            <a:r>
+              <a:t>🔐 KMS Key Management</a:t>
+            </a:r>
+          </a:p>
+          <a:p>
+            <a:pPr>
+              <a:spcBef>
+                <a:spcPts val="400"/>
+              </a:spcBef>
+              <a:defRPr sz="1400"/>
+            </a:pPr>
+            <a:r>
+              <a:t>  • Multi-cloud: AWS KMS, GCP KMS, Azure Key Vault</a:t>
+            </a:r>
+          </a:p>
+          <a:p>
+            <a:pPr>
+              <a:spcBef>
+                <a:spcPts val="400"/>
+              </a:spcBef>
+              <a:defRPr sz="1400"/>
+            </a:pPr>
+            <a:r>
+              <a:t>  • AES-256 encryption, RSA-4096 keys, 90-day rotation</a:t>
+            </a:r>
+          </a:p>
+          <a:p>
+            <a:pPr>
+              <a:spcBef>
+                <a:spcPts val="400"/>
+              </a:spcBef>
+              <a:defRPr sz="1400"/>
+            </a:pPr>
+          </a:p>
+          <a:p>
+            <a:pPr>
+              <a:spcBef>
+                <a:spcPts val="400"/>
+              </a:spcBef>
+              <a:defRPr sz="1400"/>
+            </a:pPr>
+            <a:r>
+              <a:t>🔒 mTLS Mutual Authentication</a:t>
+            </a:r>
+          </a:p>
+          <a:p>
+            <a:pPr>
+              <a:spcBef>
+                <a:spcPts val="400"/>
+              </a:spcBef>
+              <a:defRPr sz="1400"/>
+            </a:pPr>
+            <a:r>
+              <a:t>  • X.509 certificates, CRL/OCSP checking, certificate pinning</a:t>
+            </a:r>
+          </a:p>
+          <a:p>
+            <a:pPr>
+              <a:spcBef>
+                <a:spcPts val="400"/>
+              </a:spcBef>
+              <a:defRPr sz="1400"/>
+            </a:pPr>
+          </a:p>
+          <a:p>
+            <a:pPr>
+              <a:spcBef>
+                <a:spcPts val="400"/>
+              </a:spcBef>
+              <a:defRPr sz="1400"/>
+            </a:pPr>
+            <a:r>
+              <a:t>🔑 Advanced API Key Management</a:t>
+            </a:r>
+          </a:p>
+          <a:p>
+            <a:pPr>
+              <a:spcBef>
+                <a:spcPts val="400"/>
+              </a:spcBef>
+              <a:defRPr sz="1400"/>
+            </a:pPr>
+            <a:r>
+              <a:t>  • Scoped permissions, rate limiting, automatic expiration</a:t>
+            </a:r>
+          </a:p>
+          <a:p>
+            <a:pPr>
+              <a:spcBef>
+                <a:spcPts val="400"/>
+              </a:spcBef>
+              <a:defRPr sz="1400"/>
+            </a:pPr>
+          </a:p>
+          <a:p>
+            <a:pPr>
+              <a:spcBef>
+                <a:spcPts val="400"/>
+              </a:spcBef>
+              <a:defRPr sz="1400"/>
+            </a:pPr>
+            <a:r>
+              <a:t>🛡️ WireGuard Enterprise VPN</a:t>
+            </a:r>
+          </a:p>
+          <a:p>
+            <a:pPr>
+              <a:spcBef>
+                <a:spcPts val="400"/>
+              </a:spcBef>
+              <a:defRPr sz="1400"/>
+            </a:pPr>
+            <a:r>
+              <a:t>  • Zero-trust architecture, ChaCha20-Poly1305 encryption</a:t>
+            </a:r>
+          </a:p>
+          <a:p>
+            <a:pPr>
+              <a:spcBef>
+                <a:spcPts val="400"/>
+              </a:spcBef>
+              <a:defRPr sz="1400"/>
+            </a:pPr>
+          </a:p>
+          <a:p>
+            <a:pPr>
+              <a:spcBef>
+                <a:spcPts val="400"/>
+              </a:spcBef>
+              <a:defRPr sz="1400"/>
+            </a:pPr>
+            <a:r>
+              <a:t>📝 Audit Logging &amp; Compliance</a:t>
+            </a:r>
+          </a:p>
+          <a:p>
+            <a:pPr>
+              <a:spcBef>
+                <a:spcPts val="400"/>
+              </a:spcBef>
+              <a:defRPr sz="1400"/>
+            </a:pPr>
+            <a:r>
+              <a:t>  • SOC 2 Type II ready, PCI DSS, GDPR compliant</a:t>
+            </a:r>
+          </a:p>
+          <a:p>
+            <a:pPr>
+              <a:spcBef>
+                <a:spcPts val="400"/>
+              </a:spcBef>
+              <a:defRPr sz="1400"/>
+            </a:pPr>
+            <a:r>
+              <a:t>  • 24/7 security operations, quarterly penetration testing</a:t>
+            </a:r>
+          </a:p>
+        </p:txBody>
+      </p:sp>
+    </p:spTree>
+  </p:cSld>
+  <p:clrMapOvr>
+    <a:masterClrMapping/>
+  </p:clrMapOvr>
+</p:sld>
+</file>
+
+<file path=ppt/slides/slide5.xml><?xml version="1.0" encoding="utf-8"?>
 <p:sld xmlns:a="http://schemas.openxmlformats.org/drawingml/2006/main" xmlns:p="http://schemas.openxmlformats.org/presentationml/2006/main" xmlns:r="http://schemas.openxmlformats.org/officeDocument/2006/relationships">
   <p:cSld>
     <p:spTree>
@@ -3979,7 +4166,7 @@
                         <a:defRPr sz="1100"/>
                       </a:pPr>
                       <a:r>
-                        <a:t>Fast response guarantee</a:t>
+                        <a:t>Fast response</a:t>
                       </a:r>
                     </a:p>
                   </a:txBody>
@@ -4047,7 +4234,7 @@
                         <a:defRPr sz="1100"/>
                       </a:pPr>
                       <a:r>
-                        <a:t>Performance Boost</a:t>
+                        <a:t>Performance</a:t>
                       </a:r>
                     </a:p>
                   </a:txBody>
@@ -4085,7 +4272,7 @@
                         <a:defRPr sz="1100"/>
                       </a:pPr>
                       <a:r>
-                        <a:t>Request Coalescing optimization</a:t>
+                        <a:t>Request Coalescing</a:t>
                       </a:r>
                     </a:p>
                   </a:txBody>
@@ -4106,7 +4293,7 @@
                         <a:defRPr sz="1100"/>
                       </a:pPr>
                       <a:r>
-                        <a:t>Batch Processing</a:t>
+                        <a:t>Batch Process</a:t>
                       </a:r>
                     </a:p>
                   </a:txBody>
@@ -4136,7 +4323,7 @@
                         <a:defRPr sz="1100"/>
                       </a:pPr>
                       <a:r>
-                        <a:t>Concurrent computation</a:t>
+                        <a:t>Concurrent calculation</a:t>
                       </a:r>
                     </a:p>
                   </a:txBody>
@@ -4155,7 +4342,7 @@
 </p:sld>
 </file>
 
-<file path=ppt/slides/slide5.xml><?xml version="1.0" encoding="utf-8"?>
+<file path=ppt/slides/slide6.xml><?xml version="1.0" encoding="utf-8"?>
 <p:sld xmlns:a="http://schemas.openxmlformats.org/drawingml/2006/main" xmlns:p="http://schemas.openxmlformats.org/presentationml/2006/main" xmlns:r="http://schemas.openxmlformats.org/officeDocument/2006/relationships">
   <p:cSld>
     <p:spTree>
@@ -4270,9 +4457,9 @@
           <a:p>
             <a:pPr>
               <a:spcBef>
-                <a:spcPts val="600"/>
-              </a:spcBef>
-              <a:defRPr sz="1600"/>
+                <a:spcPts val="400"/>
+              </a:spcBef>
+              <a:defRPr sz="1400"/>
             </a:pPr>
             <a:r>
               <a:t>1. Industry's Only Dual-Algorithm Validation System</a:t>
@@ -4281,58 +4468,36 @@
           <a:p>
             <a:pPr>
               <a:spcBef>
-                <a:spcPts val="600"/>
-              </a:spcBef>
-              <a:defRPr sz="1600"/>
-            </a:pPr>
-            <a:r>
-              <a:t>   Ensures calculation accuracy, avoids investment errors</a:t>
-            </a:r>
-          </a:p>
-          <a:p>
-            <a:pPr>
-              <a:spcBef>
-                <a:spcPts val="600"/>
-              </a:spcBef>
-              <a:defRPr sz="1600"/>
-            </a:pPr>
-          </a:p>
-          <a:p>
-            <a:pPr>
-              <a:spcBef>
-                <a:spcPts val="600"/>
-              </a:spcBef>
-              <a:defRPr sz="1600"/>
-            </a:pPr>
-            <a:r>
-              <a:t>2. 9.8x Performance Boost with Request Coalescing</a:t>
-            </a:r>
-          </a:p>
-          <a:p>
-            <a:pPr>
-              <a:spcBef>
-                <a:spcPts val="600"/>
-              </a:spcBef>
-              <a:defRPr sz="1600"/>
-            </a:pPr>
-            <a:r>
-              <a:t>   Industry-leading concurrent request merging technology</a:t>
-            </a:r>
-          </a:p>
-          <a:p>
-            <a:pPr>
-              <a:spcBef>
-                <a:spcPts val="600"/>
-              </a:spcBef>
-              <a:defRPr sz="1600"/>
-            </a:pPr>
-          </a:p>
-          <a:p>
-            <a:pPr>
-              <a:spcBef>
-                <a:spcPts val="600"/>
-              </a:spcBef>
-              <a:defRPr sz="1600"/>
+                <a:spcPts val="400"/>
+              </a:spcBef>
+              <a:defRPr sz="1400"/>
+            </a:pPr>
+          </a:p>
+          <a:p>
+            <a:pPr>
+              <a:spcBef>
+                <a:spcPts val="400"/>
+              </a:spcBef>
+              <a:defRPr sz="1400"/>
+            </a:pPr>
+            <a:r>
+              <a:t>2. 9.8x Performance via Request Coalescing</a:t>
+            </a:r>
+          </a:p>
+          <a:p>
+            <a:pPr>
+              <a:spcBef>
+                <a:spcPts val="400"/>
+              </a:spcBef>
+              <a:defRPr sz="1400"/>
+            </a:pPr>
+          </a:p>
+          <a:p>
+            <a:pPr>
+              <a:spcBef>
+                <a:spcPts val="400"/>
+              </a:spcBef>
+              <a:defRPr sz="1400"/>
             </a:pPr>
             <a:r>
               <a:t>3. Professional-Grade Treasury Management</a:t>
@@ -4341,28 +4506,17 @@
           <a:p>
             <a:pPr>
               <a:spcBef>
-                <a:spcPts val="600"/>
-              </a:spcBef>
-              <a:defRPr sz="1600"/>
-            </a:pPr>
-            <a:r>
-              <a:t>   Institutional investor-level BTC inventory management</a:t>
-            </a:r>
-          </a:p>
-          <a:p>
-            <a:pPr>
-              <a:spcBef>
-                <a:spcPts val="600"/>
-              </a:spcBef>
-              <a:defRPr sz="1600"/>
-            </a:pPr>
-          </a:p>
-          <a:p>
-            <a:pPr>
-              <a:spcBef>
-                <a:spcPts val="600"/>
-              </a:spcBef>
-              <a:defRPr sz="1600"/>
+                <a:spcPts val="400"/>
+              </a:spcBef>
+              <a:defRPr sz="1400"/>
+            </a:pPr>
+          </a:p>
+          <a:p>
+            <a:pPr>
+              <a:spcBef>
+                <a:spcPts val="400"/>
+              </a:spcBef>
+              <a:defRPr sz="1400"/>
             </a:pPr>
             <a:r>
               <a:t>4. 10 Intelligent Signal Aggregation Modules</a:t>
@@ -4371,28 +4525,17 @@
           <a:p>
             <a:pPr>
               <a:spcBef>
-                <a:spcPts val="600"/>
-              </a:spcBef>
-              <a:defRPr sz="1600"/>
-            </a:pPr>
-            <a:r>
-              <a:t>   Integrates technical analysis, on-chain data, derivatives markets</a:t>
-            </a:r>
-          </a:p>
-          <a:p>
-            <a:pPr>
-              <a:spcBef>
-                <a:spcPts val="600"/>
-              </a:spcBef>
-              <a:defRPr sz="1600"/>
-            </a:pPr>
-          </a:p>
-          <a:p>
-            <a:pPr>
-              <a:spcBef>
-                <a:spcPts val="600"/>
-              </a:spcBef>
-              <a:defRPr sz="1600"/>
+                <a:spcPts val="400"/>
+              </a:spcBef>
+              <a:defRPr sz="1400"/>
+            </a:pPr>
+          </a:p>
+          <a:p>
+            <a:pPr>
+              <a:spcBef>
+                <a:spcPts val="400"/>
+              </a:spcBef>
+              <a:defRPr sz="1400"/>
             </a:pPr>
             <a:r>
               <a:t>5. Enterprise-Grade Security &amp; Compliance</a:t>
@@ -4401,42 +4544,31 @@
           <a:p>
             <a:pPr>
               <a:spcBef>
-                <a:spcPts val="600"/>
-              </a:spcBef>
-              <a:defRPr sz="1600"/>
-            </a:pPr>
-            <a:r>
-              <a:t>   KMS encryption, mTLS authentication, SOC 2 ready</a:t>
-            </a:r>
-          </a:p>
-          <a:p>
-            <a:pPr>
-              <a:spcBef>
-                <a:spcPts val="600"/>
-              </a:spcBef>
-              <a:defRPr sz="1600"/>
-            </a:pPr>
-          </a:p>
-          <a:p>
-            <a:pPr>
-              <a:spcBef>
-                <a:spcPts val="600"/>
-              </a:spcBef>
-              <a:defRPr sz="1600"/>
-            </a:pPr>
-            <a:r>
-              <a:t>6. Complete Page Isolation Architecture</a:t>
-            </a:r>
-          </a:p>
-          <a:p>
-            <a:pPr>
-              <a:spcBef>
-                <a:spcPts val="600"/>
-              </a:spcBef>
-              <a:defRPr sz="1600"/>
-            </a:pPr>
-            <a:r>
-              <a:t>   Modular design, flexible scaling</a:t>
+                <a:spcPts val="400"/>
+              </a:spcBef>
+              <a:defRPr sz="1400"/>
+            </a:pPr>
+            <a:r>
+              <a:t>   KMS encryption, mTLS auth, SOC 2 ready</a:t>
+            </a:r>
+          </a:p>
+          <a:p>
+            <a:pPr>
+              <a:spcBef>
+                <a:spcPts val="400"/>
+              </a:spcBef>
+              <a:defRPr sz="1400"/>
+            </a:pPr>
+          </a:p>
+          <a:p>
+            <a:pPr>
+              <a:spcBef>
+                <a:spcPts val="400"/>
+              </a:spcBef>
+              <a:defRPr sz="1400"/>
+            </a:pPr>
+            <a:r>
+              <a:t>6. Fully Page-Isolated Architecture</a:t>
             </a:r>
           </a:p>
         </p:txBody>
@@ -4449,7 +4581,7 @@
 </p:sld>
 </file>
 
-<file path=ppt/slides/slide6.xml><?xml version="1.0" encoding="utf-8"?>
+<file path=ppt/slides/slide7.xml><?xml version="1.0" encoding="utf-8"?>
 <p:sld xmlns:a="http://schemas.openxmlformats.org/drawingml/2006/main" xmlns:p="http://schemas.openxmlformats.org/presentationml/2006/main" xmlns:r="http://schemas.openxmlformats.org/officeDocument/2006/relationships">
   <p:cSld>
     <p:spTree>
@@ -4564,9 +4696,9 @@
           <a:p>
             <a:pPr>
               <a:spcBef>
-                <a:spcPts val="600"/>
-              </a:spcBef>
-              <a:defRPr sz="1600"/>
+                <a:spcPts val="400"/>
+              </a:spcBef>
+              <a:defRPr sz="1400"/>
             </a:pPr>
             <a:r>
               <a:t>Large Mining Farms</a:t>
@@ -4575,39 +4707,28 @@
           <a:p>
             <a:pPr>
               <a:spcBef>
-                <a:spcPts val="600"/>
-              </a:spcBef>
-              <a:defRPr sz="1600"/>
-            </a:pPr>
-            <a:r>
-              <a:t>   • Managing thousands of miners, real-time revenue monitoring</a:t>
-            </a:r>
-          </a:p>
-          <a:p>
-            <a:pPr>
-              <a:spcBef>
-                <a:spcPts val="600"/>
-              </a:spcBef>
-              <a:defRPr sz="1600"/>
-            </a:pPr>
-            <a:r>
-              <a:t>   • Value: 10x calculation efficiency, 15-20% power cost savings</a:t>
-            </a:r>
-          </a:p>
-          <a:p>
-            <a:pPr>
-              <a:spcBef>
-                <a:spcPts val="600"/>
-              </a:spcBef>
-              <a:defRPr sz="1600"/>
-            </a:pPr>
-          </a:p>
-          <a:p>
-            <a:pPr>
-              <a:spcBef>
-                <a:spcPts val="600"/>
-              </a:spcBef>
-              <a:defRPr sz="1600"/>
+                <a:spcPts val="400"/>
+              </a:spcBef>
+              <a:defRPr sz="1400"/>
+            </a:pPr>
+            <a:r>
+              <a:t>  • 15,000+ miners, 10x efficiency, 15-20% cost savings</a:t>
+            </a:r>
+          </a:p>
+          <a:p>
+            <a:pPr>
+              <a:spcBef>
+                <a:spcPts val="400"/>
+              </a:spcBef>
+              <a:defRPr sz="1400"/>
+            </a:pPr>
+          </a:p>
+          <a:p>
+            <a:pPr>
+              <a:spcBef>
+                <a:spcPts val="400"/>
+              </a:spcBef>
+              <a:defRPr sz="1400"/>
             </a:pPr>
             <a:r>
               <a:t>Hosting Providers</a:t>
@@ -4616,39 +4737,28 @@
           <a:p>
             <a:pPr>
               <a:spcBef>
-                <a:spcPts val="600"/>
-              </a:spcBef>
-              <a:defRPr sz="1600"/>
-            </a:pPr>
-            <a:r>
-              <a:t>   • Transparent pricing, real-time revenue tracking, professional reports</a:t>
-            </a:r>
-          </a:p>
-          <a:p>
-            <a:pPr>
-              <a:spcBef>
-                <a:spcPts val="600"/>
-              </a:spcBef>
-              <a:defRPr sz="1600"/>
-            </a:pPr>
-            <a:r>
-              <a:t>   • Value: 40% increase in customer trust, standardized services</a:t>
-            </a:r>
-          </a:p>
-          <a:p>
-            <a:pPr>
-              <a:spcBef>
-                <a:spcPts val="600"/>
-              </a:spcBef>
-              <a:defRPr sz="1600"/>
-            </a:pPr>
-          </a:p>
-          <a:p>
-            <a:pPr>
-              <a:spcBef>
-                <a:spcPts val="600"/>
-              </a:spcBef>
-              <a:defRPr sz="1600"/>
+                <a:spcPts val="400"/>
+              </a:spcBef>
+              <a:defRPr sz="1400"/>
+            </a:pPr>
+            <a:r>
+              <a:t>  • 300+ clients, 40% trust increase, standardized service</a:t>
+            </a:r>
+          </a:p>
+          <a:p>
+            <a:pPr>
+              <a:spcBef>
+                <a:spcPts val="400"/>
+              </a:spcBef>
+              <a:defRPr sz="1400"/>
+            </a:pPr>
+          </a:p>
+          <a:p>
+            <a:pPr>
+              <a:spcBef>
+                <a:spcPts val="400"/>
+              </a:spcBef>
+              <a:defRPr sz="1400"/>
             </a:pPr>
             <a:r>
               <a:t>Institutional Investors</a:t>
@@ -4657,263 +4767,12 @@
           <a:p>
             <a:pPr>
               <a:spcBef>
-                <a:spcPts val="600"/>
-              </a:spcBef>
-              <a:defRPr sz="1600"/>
-            </a:pPr>
-            <a:r>
-              <a:t>   • ROI evaluation, BTC inventory management, optimized selling strategies</a:t>
-            </a:r>
-          </a:p>
-          <a:p>
-            <a:pPr>
-              <a:spcBef>
-                <a:spcPts val="600"/>
-              </a:spcBef>
-              <a:defRPr sz="1600"/>
-            </a:pPr>
-            <a:r>
-              <a:t>   • Value: Data-driven decisions, 10-15% improved selling timing</a:t>
-            </a:r>
-          </a:p>
-        </p:txBody>
-      </p:sp>
-    </p:spTree>
-  </p:cSld>
-  <p:clrMapOvr>
-    <a:masterClrMapping/>
-  </p:clrMapOvr>
-</p:sld>
-</file>
-
-<file path=ppt/slides/slide7.xml><?xml version="1.0" encoding="utf-8"?>
-<p:sld xmlns:a="http://schemas.openxmlformats.org/drawingml/2006/main" xmlns:p="http://schemas.openxmlformats.org/presentationml/2006/main" xmlns:r="http://schemas.openxmlformats.org/officeDocument/2006/relationships">
-  <p:cSld>
-    <p:spTree>
-      <p:nvGrpSpPr>
-        <p:cNvPr id="1" name=""/>
-        <p:cNvGrpSpPr/>
-        <p:nvPr/>
-      </p:nvGrpSpPr>
-      <p:grpSpPr/>
-      <p:sp>
-        <p:nvSpPr>
-          <p:cNvPr id="2" name="TextBox 1"/>
-          <p:cNvSpPr txBox="1"/>
-          <p:nvPr/>
-        </p:nvSpPr>
-        <p:spPr>
-          <a:xfrm>
-            <a:off x="457200" y="457200"/>
-            <a:ext cx="8229600" cy="731520"/>
-          </a:xfrm>
-          <a:prstGeom prst="rect">
-            <a:avLst/>
-          </a:prstGeom>
-          <a:noFill/>
-        </p:spPr>
-        <p:txBody>
-          <a:bodyPr wrap="none">
-            <a:spAutoFit/>
-          </a:bodyPr>
-          <a:lstStyle/>
-          <a:p>
-            <a:pPr>
-              <a:defRPr sz="3600" b="1">
-                <a:solidFill>
-                  <a:srgbClr val="2C3E50"/>
-                </a:solidFill>
-              </a:defRPr>
-            </a:pPr>
-            <a:r>
-              <a:t>Customer Success Stories</a:t>
-            </a:r>
-          </a:p>
-        </p:txBody>
-      </p:sp>
-      <p:sp>
-        <p:nvSpPr>
-          <p:cNvPr id="3" name="Rectangle 2"/>
-          <p:cNvSpPr/>
-          <p:nvPr/>
-        </p:nvSpPr>
-        <p:spPr>
-          <a:xfrm>
-            <a:off x="457200" y="1143000"/>
-            <a:ext cx="8229600" cy="45720"/>
-          </a:xfrm>
-          <a:prstGeom prst="rect">
-            <a:avLst/>
-          </a:prstGeom>
-          <a:solidFill>
-            <a:srgbClr val="F39C12"/>
-          </a:solidFill>
-          <a:ln>
-            <a:solidFill>
-              <a:srgbClr val="F39C12"/>
-            </a:solidFill>
-          </a:ln>
-        </p:spPr>
-        <p:style>
-          <a:lnRef idx="1">
-            <a:schemeClr val="accent1"/>
-          </a:lnRef>
-          <a:fillRef idx="3">
-            <a:schemeClr val="accent1"/>
-          </a:fillRef>
-          <a:effectRef idx="2">
-            <a:schemeClr val="accent1"/>
-          </a:effectRef>
-          <a:fontRef idx="minor">
-            <a:schemeClr val="lt1"/>
-          </a:fontRef>
-        </p:style>
-        <p:txBody>
-          <a:bodyPr rtlCol="0" anchor="ctr"/>
-          <a:lstStyle/>
-          <a:p>
-            <a:pPr algn="ctr"/>
-          </a:p>
-        </p:txBody>
-      </p:sp>
-      <p:sp>
-        <p:nvSpPr>
-          <p:cNvPr id="4" name="TextBox 3"/>
-          <p:cNvSpPr txBox="1"/>
-          <p:nvPr/>
-        </p:nvSpPr>
-        <p:spPr>
-          <a:xfrm>
-            <a:off x="457200" y="1463040"/>
-            <a:ext cx="8229600" cy="4114800"/>
-          </a:xfrm>
-          <a:prstGeom prst="rect">
-            <a:avLst/>
-          </a:prstGeom>
-          <a:noFill/>
-        </p:spPr>
-        <p:txBody>
-          <a:bodyPr wrap="square">
-            <a:spAutoFit/>
-          </a:bodyPr>
-          <a:lstStyle/>
-          <a:p/>
-          <a:p>
-            <a:pPr>
-              <a:spcBef>
-                <a:spcPts val="600"/>
-              </a:spcBef>
-              <a:defRPr sz="1600"/>
-            </a:pPr>
-            <a:r>
-              <a:t>Case 1: 100MW Mining Farm</a:t>
-            </a:r>
-          </a:p>
-          <a:p>
-            <a:pPr>
-              <a:spcBef>
-                <a:spcPts val="600"/>
-              </a:spcBef>
-              <a:defRPr sz="1600"/>
-            </a:pPr>
-            <a:r>
-              <a:t>   • Managing 15,000+ miners</a:t>
-            </a:r>
-          </a:p>
-          <a:p>
-            <a:pPr>
-              <a:spcBef>
-                <a:spcPts val="600"/>
-              </a:spcBef>
-              <a:defRPr sz="1600"/>
-            </a:pPr>
-            <a:r>
-              <a:t>   • Results: Revenue calculation from 2 hours to 5 minutes</a:t>
-            </a:r>
-          </a:p>
-          <a:p>
-            <a:pPr>
-              <a:spcBef>
-                <a:spcPts val="600"/>
-              </a:spcBef>
-              <a:defRPr sz="1600"/>
-            </a:pPr>
-            <a:r>
-              <a:t>             Annual power cost savings of $1.8M</a:t>
-            </a:r>
-          </a:p>
-          <a:p>
-            <a:pPr>
-              <a:spcBef>
-                <a:spcPts val="600"/>
-              </a:spcBef>
-              <a:defRPr sz="1600"/>
-            </a:pPr>
-            <a:r>
-              <a:t>             70% reduction in customer complaints</a:t>
-            </a:r>
-          </a:p>
-          <a:p>
-            <a:pPr>
-              <a:spcBef>
-                <a:spcPts val="600"/>
-              </a:spcBef>
-              <a:defRPr sz="1600"/>
-            </a:pPr>
-          </a:p>
-          <a:p>
-            <a:pPr>
-              <a:spcBef>
-                <a:spcPts val="600"/>
-              </a:spcBef>
-              <a:defRPr sz="1600"/>
-            </a:pPr>
-            <a:r>
-              <a:t>Case 2: Hosting Service Provider</a:t>
-            </a:r>
-          </a:p>
-          <a:p>
-            <a:pPr>
-              <a:spcBef>
-                <a:spcPts val="600"/>
-              </a:spcBef>
-              <a:defRPr sz="1600"/>
-            </a:pPr>
-            <a:r>
-              <a:t>   • Providing hosting for 300+ clients</a:t>
-            </a:r>
-          </a:p>
-          <a:p>
-            <a:pPr>
-              <a:spcBef>
-                <a:spcPts val="600"/>
-              </a:spcBef>
-              <a:defRPr sz="1600"/>
-            </a:pPr>
-            <a:r>
-              <a:t>   • Results: 60% reduction in customer management costs</a:t>
-            </a:r>
-          </a:p>
-          <a:p>
-            <a:pPr>
-              <a:spcBef>
-                <a:spcPts val="600"/>
-              </a:spcBef>
-              <a:defRPr sz="1600"/>
-            </a:pPr>
-            <a:r>
-              <a:t>             35% increase in new customer conversion</a:t>
-            </a:r>
-          </a:p>
-          <a:p>
-            <a:pPr>
-              <a:spcBef>
-                <a:spcPts val="600"/>
-              </a:spcBef>
-              <a:defRPr sz="1600"/>
-            </a:pPr>
-            <a:r>
-              <a:t>             $500K/year additional service revenue</a:t>
+                <a:spcPts val="400"/>
+              </a:spcBef>
+              <a:defRPr sz="1400"/>
+            </a:pPr>
+            <a:r>
+              <a:t>  • ROI evaluation, BTC inventory, 10-15% better timing</a:t>
             </a:r>
           </a:p>
         </p:txBody>
@@ -5169,7 +5028,7 @@
                         <a:defRPr sz="1100"/>
                       </a:pPr>
                       <a:r>
-                        <a:t>Individual miners</a:t>
+                        <a:t>Individual</a:t>
                       </a:r>
                     </a:p>
                   </a:txBody>
@@ -5239,7 +5098,7 @@
                         <a:defRPr sz="1100"/>
                       </a:pPr>
                       <a:r>
-                        <a:t>Small-medium farms</a:t>
+                        <a:t>Small-medium</a:t>
                       </a:r>
                     </a:p>
                   </a:txBody>
@@ -5258,7 +5117,7 @@
                         <a:defRPr sz="1100"/>
                       </a:pPr>
                       <a:r>
-                        <a:t>Batch calc, analytics, CRM</a:t>
+                        <a:t>Batch, analytics, CRM</a:t>
                       </a:r>
                     </a:p>
                   </a:txBody>
@@ -5324,7 +5183,7 @@
                         <a:defRPr sz="1100"/>
                       </a:pPr>
                       <a:r>
-                        <a:t>Full features, Treasury, priority support</a:t>
+                        <a:t>Full features, Treasury</a:t>
                       </a:r>
                     </a:p>
                   </a:txBody>
@@ -5360,7 +5219,7 @@
                         <a:defRPr sz="1100"/>
                       </a:pPr>
                       <a:r>
-                        <a:t>Custom quote</a:t>
+                        <a:t>Custom</a:t>
                       </a:r>
                     </a:p>
                   </a:txBody>
@@ -5379,7 +5238,7 @@
                         <a:defRPr sz="1100"/>
                       </a:pPr>
                       <a:r>
-                        <a:t>Ultra-large scale</a:t>
+                        <a:t>Ultra-large</a:t>
                       </a:r>
                     </a:p>
                   </a:txBody>
@@ -5398,7 +5257,7 @@
                         <a:defRPr sz="1100"/>
                       </a:pPr>
                       <a:r>
-                        <a:t>Private deployment, dedicated servers</a:t>
+                        <a:t>Private deployment</a:t>
                       </a:r>
                     </a:p>
                   </a:txBody>
@@ -5536,9 +5395,9 @@
           <a:p>
             <a:pPr>
               <a:spcBef>
-                <a:spcPts val="600"/>
-              </a:spcBef>
-              <a:defRPr sz="1600"/>
+                <a:spcPts val="400"/>
+              </a:spcBef>
+              <a:defRPr sz="1400"/>
             </a:pPr>
             <a:r>
               <a:t>Business Inquiries</a:t>
@@ -5547,28 +5406,28 @@
           <a:p>
             <a:pPr>
               <a:spcBef>
-                <a:spcPts val="600"/>
-              </a:spcBef>
-              <a:defRPr sz="1600"/>
-            </a:pPr>
-            <a:r>
-              <a:t>   sales@hashinsight.io</a:t>
-            </a:r>
-          </a:p>
-          <a:p>
-            <a:pPr>
-              <a:spcBef>
-                <a:spcPts val="600"/>
-              </a:spcBef>
-              <a:defRPr sz="1600"/>
-            </a:pPr>
-          </a:p>
-          <a:p>
-            <a:pPr>
-              <a:spcBef>
-                <a:spcPts val="600"/>
-              </a:spcBef>
-              <a:defRPr sz="1600"/>
+                <a:spcPts val="400"/>
+              </a:spcBef>
+              <a:defRPr sz="1400"/>
+            </a:pPr>
+            <a:r>
+              <a:t>  sales@hashinsight.io</a:t>
+            </a:r>
+          </a:p>
+          <a:p>
+            <a:pPr>
+              <a:spcBef>
+                <a:spcPts val="400"/>
+              </a:spcBef>
+              <a:defRPr sz="1400"/>
+            </a:pPr>
+          </a:p>
+          <a:p>
+            <a:pPr>
+              <a:spcBef>
+                <a:spcPts val="400"/>
+              </a:spcBef>
+              <a:defRPr sz="1400"/>
             </a:pPr>
             <a:r>
               <a:t>Technical Support</a:t>
@@ -5577,28 +5436,28 @@
           <a:p>
             <a:pPr>
               <a:spcBef>
-                <a:spcPts val="600"/>
-              </a:spcBef>
-              <a:defRPr sz="1600"/>
-            </a:pPr>
-            <a:r>
-              <a:t>   support@hashinsight.io</a:t>
-            </a:r>
-          </a:p>
-          <a:p>
-            <a:pPr>
-              <a:spcBef>
-                <a:spcPts val="600"/>
-              </a:spcBef>
-              <a:defRPr sz="1600"/>
-            </a:pPr>
-          </a:p>
-          <a:p>
-            <a:pPr>
-              <a:spcBef>
-                <a:spcPts val="600"/>
-              </a:spcBef>
-              <a:defRPr sz="1600"/>
+                <a:spcPts val="400"/>
+              </a:spcBef>
+              <a:defRPr sz="1400"/>
+            </a:pPr>
+            <a:r>
+              <a:t>  support@hashinsight.io</a:t>
+            </a:r>
+          </a:p>
+          <a:p>
+            <a:pPr>
+              <a:spcBef>
+                <a:spcPts val="400"/>
+              </a:spcBef>
+              <a:defRPr sz="1400"/>
+            </a:pPr>
+          </a:p>
+          <a:p>
+            <a:pPr>
+              <a:spcBef>
+                <a:spcPts val="400"/>
+              </a:spcBef>
+              <a:defRPr sz="1400"/>
             </a:pPr>
             <a:r>
               <a:t>Official Website</a:t>
@@ -5607,28 +5466,28 @@
           <a:p>
             <a:pPr>
               <a:spcBef>
-                <a:spcPts val="600"/>
-              </a:spcBef>
-              <a:defRPr sz="1600"/>
-            </a:pPr>
-            <a:r>
-              <a:t>   https://hashinsight.io</a:t>
-            </a:r>
-          </a:p>
-          <a:p>
-            <a:pPr>
-              <a:spcBef>
-                <a:spcPts val="600"/>
-              </a:spcBef>
-              <a:defRPr sz="1600"/>
-            </a:pPr>
-          </a:p>
-          <a:p>
-            <a:pPr>
-              <a:spcBef>
-                <a:spcPts val="600"/>
-              </a:spcBef>
-              <a:defRPr sz="1600"/>
+                <a:spcPts val="400"/>
+              </a:spcBef>
+              <a:defRPr sz="1400"/>
+            </a:pPr>
+            <a:r>
+              <a:t>  https://hashinsight.io</a:t>
+            </a:r>
+          </a:p>
+          <a:p>
+            <a:pPr>
+              <a:spcBef>
+                <a:spcPts val="400"/>
+              </a:spcBef>
+              <a:defRPr sz="1400"/>
+            </a:pPr>
+          </a:p>
+          <a:p>
+            <a:pPr>
+              <a:spcBef>
+                <a:spcPts val="400"/>
+              </a:spcBef>
+              <a:defRPr sz="1400"/>
             </a:pPr>
             <a:r>
               <a:t>Enterprise Support</a:t>
@@ -5637,34 +5496,12 @@
           <a:p>
             <a:pPr>
               <a:spcBef>
-                <a:spcPts val="600"/>
-              </a:spcBef>
-              <a:defRPr sz="1600"/>
-            </a:pPr>
-            <a:r>
-              <a:t>   • 24/7 technical support hotline</a:t>
-            </a:r>
-          </a:p>
-          <a:p>
-            <a:pPr>
-              <a:spcBef>
-                <a:spcPts val="600"/>
-              </a:spcBef>
-              <a:defRPr sz="1600"/>
-            </a:pPr>
-            <a:r>
-              <a:t>   • 1-hour response SLA</a:t>
-            </a:r>
-          </a:p>
-          <a:p>
-            <a:pPr>
-              <a:spcBef>
-                <a:spcPts val="600"/>
-              </a:spcBef>
-              <a:defRPr sz="1600"/>
-            </a:pPr>
-            <a:r>
-              <a:t>   • Dedicated customer success manager</a:t>
+                <a:spcPts val="400"/>
+              </a:spcBef>
+              <a:defRPr sz="1400"/>
+            </a:pPr>
+            <a:r>
+              <a:t>  • 24/7 technical hotline, 1-hour response SLA</a:t>
             </a:r>
           </a:p>
         </p:txBody>

</xml_diff>

<commit_message>
Add new product and benchmark documentation to the platform
Adds new HTML and PDF files for product introduction, operations manual, performance benchmark whitepaper, and data source reliability. Updates existing HTML files with optimized CSS and content.

Replit-Commit-Author: Agent
Replit-Commit-Session-Id: f5874770-ab78-47d7-a201-29323951684a
Replit-Commit-Checkpoint-Type: intermediate_checkpoint
Replit-Commit-Screenshot-Url: https://storage.googleapis.com/screenshot-production-us-central1/c0c817cd-9663-4b96-9a33-086737bed5dc/f5874770-ab78-47d7-a201-29323951684a/6FOXFth
</commit_message>
<xml_diff>
--- a/HashInsight_Product_Introduction_EN.pptx
+++ b/HashInsight_Product_Introduction_EN.pptx
@@ -3313,7 +3313,7 @@
               <a:defRPr sz="1400"/>
             </a:pPr>
             <a:r>
-              <a:t>  Mining farms, hosting providers, large miners, institutional investors</a:t>
+              <a:t>  Mining farms, hosting providers, institutional investors</a:t>
             </a:r>
           </a:p>
           <a:p>
@@ -3332,7 +3332,7 @@
               <a:defRPr sz="1400"/>
             </a:pPr>
             <a:r>
-              <a:t>Core Value Proposition</a:t>
+              <a:t>Core Value</a:t>
             </a:r>
           </a:p>
           <a:p>
@@ -3343,7 +3343,7 @@
               <a:defRPr sz="1400"/>
             </a:pPr>
             <a:r>
-              <a:t>  Data-driven decisions, professional financial management</a:t>
+              <a:t>  Data-driven decisions, professional management</a:t>
             </a:r>
           </a:p>
           <a:p>
@@ -3353,9 +3353,6 @@
               </a:spcBef>
               <a:defRPr sz="1400"/>
             </a:pPr>
-            <a:r>
-              <a:t>  Transparent customer service</a:t>
-            </a:r>
           </a:p>
           <a:p>
             <a:pPr>
@@ -3364,6 +3361,9 @@
               </a:spcBef>
               <a:defRPr sz="1400"/>
             </a:pPr>
+            <a:r>
+              <a:t>Technical Guarantees</a:t>
+            </a:r>
           </a:p>
           <a:p>
             <a:pPr>
@@ -3373,18 +3373,7 @@
               <a:defRPr sz="1400"/>
             </a:pPr>
             <a:r>
-              <a:t>Technical Guarantees</a:t>
-            </a:r>
-          </a:p>
-          <a:p>
-            <a:pPr>
-              <a:spcBef>
-                <a:spcPts val="400"/>
-              </a:spcBef>
-              <a:defRPr sz="1400"/>
-            </a:pPr>
-            <a:r>
-              <a:t>  99.95% SLA, 9.8x performance, enterprise-grade security</a:t>
+              <a:t>  99.95% SLA, 9.8x performance, enterprise security</a:t>
             </a:r>
           </a:p>
         </p:txBody>
@@ -3437,7 +3426,7 @@
               </a:defRPr>
             </a:pPr>
             <a:r>
-              <a:t>5 Core Features</a:t>
+              <a:t>5 Core Features + Dual-Algorithm</a:t>
             </a:r>
           </a:p>
         </p:txBody>
@@ -3517,7 +3506,7 @@
               <a:defRPr sz="1400"/>
             </a:pPr>
             <a:r>
-              <a:t>1. Intelligent Mining Calculator - 17+ models, dual validation</a:t>
+              <a:t>1. Intelligent Mining Calculator</a:t>
             </a:r>
           </a:p>
           <a:p>
@@ -3527,6 +3516,9 @@
               </a:spcBef>
               <a:defRPr sz="1400"/>
             </a:pPr>
+            <a:r>
+              <a:t>   Dual-Algorithm Validation: Hashrate-based + Difficulty-based</a:t>
+            </a:r>
           </a:p>
           <a:p>
             <a:pPr>
@@ -3536,7 +3528,7 @@
               <a:defRPr sz="1400"/>
             </a:pPr>
             <a:r>
-              <a:t>2. Technical Analysis Platform - 10 signal modules</a:t>
+              <a:t>   Cross-validation with ±2% tolerance</a:t>
             </a:r>
           </a:p>
           <a:p>
@@ -3555,7 +3547,7 @@
               <a:defRPr sz="1400"/>
             </a:pPr>
             <a:r>
-              <a:t>3. Treasury Management - BTC inventory, selling strategies</a:t>
+              <a:t>2. Technical Analysis - 10 signal modules</a:t>
             </a:r>
           </a:p>
           <a:p>
@@ -3574,7 +3566,7 @@
               <a:defRPr sz="1400"/>
             </a:pPr>
             <a:r>
-              <a:t>4. CRM Customer Management - Full lifecycle tracking</a:t>
+              <a:t>3. Treasury Management - BTC inventory + strategies</a:t>
             </a:r>
           </a:p>
           <a:p>
@@ -3593,7 +3585,26 @@
               <a:defRPr sz="1400"/>
             </a:pPr>
             <a:r>
-              <a:t>5. Enterprise Security - KMS, mTLS, WireGuard VPN, audit logging</a:t>
+              <a:t>4. CRM - Full lifecycle management</a:t>
+            </a:r>
+          </a:p>
+          <a:p>
+            <a:pPr>
+              <a:spcBef>
+                <a:spcPts val="400"/>
+              </a:spcBef>
+              <a:defRPr sz="1400"/>
+            </a:pPr>
+          </a:p>
+          <a:p>
+            <a:pPr>
+              <a:spcBef>
+                <a:spcPts val="400"/>
+              </a:spcBef>
+              <a:defRPr sz="1400"/>
+            </a:pPr>
+            <a:r>
+              <a:t>5. Enterprise Security - KMS, mTLS, WireGuard VPN</a:t>
             </a:r>
           </a:p>
         </p:txBody>
@@ -3726,7 +3737,7 @@
               <a:defRPr sz="1400"/>
             </a:pPr>
             <a:r>
-              <a:t>🔐 KMS Key Management</a:t>
+              <a:t>KMS Key Management - Multi-cloud, AES-256, RSA-4096</a:t>
             </a:r>
           </a:p>
           <a:p>
@@ -3737,7 +3748,7 @@
               <a:defRPr sz="1400"/>
             </a:pPr>
             <a:r>
-              <a:t>  • Multi-cloud: AWS KMS, GCP KMS, Azure Key Vault</a:t>
+              <a:t>mTLS Authentication - X.509 certificates, CRL/OCSP</a:t>
             </a:r>
           </a:p>
           <a:p>
@@ -3748,7 +3759,7 @@
               <a:defRPr sz="1400"/>
             </a:pPr>
             <a:r>
-              <a:t>  • AES-256 encryption, RSA-4096 keys, 90-day rotation</a:t>
+              <a:t>API Key Management - Scoped permissions, rate limiting</a:t>
             </a:r>
           </a:p>
           <a:p>
@@ -3758,6 +3769,9 @@
               </a:spcBef>
               <a:defRPr sz="1400"/>
             </a:pPr>
+            <a:r>
+              <a:t>WireGuard VPN - Zero-trust, ChaCha20-Poly1305</a:t>
+            </a:r>
           </a:p>
           <a:p>
             <a:pPr>
@@ -3767,7 +3781,7 @@
               <a:defRPr sz="1400"/>
             </a:pPr>
             <a:r>
-              <a:t>🔒 mTLS Mutual Authentication</a:t>
+              <a:t>Audit Logging - 7-year retention, tamper-proof</a:t>
             </a:r>
           </a:p>
           <a:p>
@@ -3777,9 +3791,6 @@
               </a:spcBef>
               <a:defRPr sz="1400"/>
             </a:pPr>
-            <a:r>
-              <a:t>  • X.509 certificates, CRL/OCSP checking, certificate pinning</a:t>
-            </a:r>
           </a:p>
           <a:p>
             <a:pPr>
@@ -3788,6 +3799,9 @@
               </a:spcBef>
               <a:defRPr sz="1400"/>
             </a:pPr>
+            <a:r>
+              <a:t>Compliance Status:</a:t>
+            </a:r>
           </a:p>
           <a:p>
             <a:pPr>
@@ -3797,7 +3811,7 @@
               <a:defRPr sz="1400"/>
             </a:pPr>
             <a:r>
-              <a:t>🔑 Advanced API Key Management</a:t>
+              <a:t>  SOC 2 Type II Ready (Q1 2026 audit scheduled)</a:t>
             </a:r>
           </a:p>
           <a:p>
@@ -3808,7 +3822,7 @@
               <a:defRPr sz="1400"/>
             </a:pPr>
             <a:r>
-              <a:t>  • Scoped permissions, rate limiting, automatic expiration</a:t>
+              <a:t>  PCI DSS Compliant (via Stripe)</a:t>
             </a:r>
           </a:p>
           <a:p>
@@ -3818,68 +3832,8 @@
               </a:spcBef>
               <a:defRPr sz="1400"/>
             </a:pPr>
-          </a:p>
-          <a:p>
-            <a:pPr>
-              <a:spcBef>
-                <a:spcPts val="400"/>
-              </a:spcBef>
-              <a:defRPr sz="1400"/>
-            </a:pPr>
-            <a:r>
-              <a:t>🛡️ WireGuard Enterprise VPN</a:t>
-            </a:r>
-          </a:p>
-          <a:p>
-            <a:pPr>
-              <a:spcBef>
-                <a:spcPts val="400"/>
-              </a:spcBef>
-              <a:defRPr sz="1400"/>
-            </a:pPr>
-            <a:r>
-              <a:t>  • Zero-trust architecture, ChaCha20-Poly1305 encryption</a:t>
-            </a:r>
-          </a:p>
-          <a:p>
-            <a:pPr>
-              <a:spcBef>
-                <a:spcPts val="400"/>
-              </a:spcBef>
-              <a:defRPr sz="1400"/>
-            </a:pPr>
-          </a:p>
-          <a:p>
-            <a:pPr>
-              <a:spcBef>
-                <a:spcPts val="400"/>
-              </a:spcBef>
-              <a:defRPr sz="1400"/>
-            </a:pPr>
-            <a:r>
-              <a:t>📝 Audit Logging &amp; Compliance</a:t>
-            </a:r>
-          </a:p>
-          <a:p>
-            <a:pPr>
-              <a:spcBef>
-                <a:spcPts val="400"/>
-              </a:spcBef>
-              <a:defRPr sz="1400"/>
-            </a:pPr>
-            <a:r>
-              <a:t>  • SOC 2 Type II ready, PCI DSS, GDPR compliant</a:t>
-            </a:r>
-          </a:p>
-          <a:p>
-            <a:pPr>
-              <a:spcBef>
-                <a:spcPts val="400"/>
-              </a:spcBef>
-              <a:defRPr sz="1400"/>
-            </a:pPr>
-            <a:r>
-              <a:t>  • 24/7 security operations, quarterly penetration testing</a:t>
+            <a:r>
+              <a:t>  GDPR Fully Compliant</a:t>
             </a:r>
           </a:p>
         </p:txBody>
@@ -4382,7 +4336,561 @@
               </a:defRPr>
             </a:pPr>
             <a:r>
-              <a:t>6 Product Highlights</a:t>
+              <a:t>Competitive Advantage</a:t>
+            </a:r>
+          </a:p>
+        </p:txBody>
+      </p:sp>
+      <p:sp>
+        <p:nvSpPr>
+          <p:cNvPr id="3" name="Rectangle 2"/>
+          <p:cNvSpPr/>
+          <p:nvPr/>
+        </p:nvSpPr>
+        <p:spPr>
+          <a:xfrm>
+            <a:off x="457200" y="1143000"/>
+            <a:ext cx="8229600" cy="45720"/>
+          </a:xfrm>
+          <a:prstGeom prst="rect">
+            <a:avLst/>
+          </a:prstGeom>
+          <a:solidFill>
+            <a:srgbClr val="F39C12"/>
+          </a:solidFill>
+        </p:spPr>
+        <p:style>
+          <a:lnRef idx="1">
+            <a:schemeClr val="accent1"/>
+          </a:lnRef>
+          <a:fillRef idx="3">
+            <a:schemeClr val="accent1"/>
+          </a:fillRef>
+          <a:effectRef idx="2">
+            <a:schemeClr val="accent1"/>
+          </a:effectRef>
+          <a:fontRef idx="minor">
+            <a:schemeClr val="lt1"/>
+          </a:fontRef>
+        </p:style>
+        <p:txBody>
+          <a:bodyPr rtlCol="0" anchor="ctr"/>
+          <a:lstStyle/>
+          <a:p>
+            <a:pPr algn="ctr"/>
+          </a:p>
+        </p:txBody>
+      </p:sp>
+      <p:graphicFrame>
+        <p:nvGraphicFramePr>
+          <p:cNvPr id="4" name="Table 3"/>
+          <p:cNvGraphicFramePr>
+            <a:graphicFrameLocks noGrp="1"/>
+          </p:cNvGraphicFramePr>
+          <p:nvPr/>
+        </p:nvGraphicFramePr>
+        <p:xfrm>
+          <a:off x="731520" y="1828800"/>
+          <a:ext cx="7680960" cy="3657600"/>
+        </p:xfrm>
+        <a:graphic>
+          <a:graphicData uri="http://schemas.openxmlformats.org/drawingml/2006/table">
+            <a:tbl>
+              <a:tblPr firstRow="1" bandRow="1">
+                <a:tableStyleId>{5C22544A-7EE6-4342-B048-85BDC9FD1C3A}</a:tableStyleId>
+              </a:tblPr>
+              <a:tblGrid>
+                <a:gridCol w="1920240"/>
+                <a:gridCol w="1920240"/>
+                <a:gridCol w="1920240"/>
+                <a:gridCol w="1920240"/>
+              </a:tblGrid>
+              <a:tr h="609600">
+                <a:tc>
+                  <a:txBody>
+                    <a:bodyPr/>
+                    <a:lstStyle/>
+                    <a:p>
+                      <a:pPr>
+                        <a:defRPr b="1" sz="1300">
+                          <a:solidFill>
+                            <a:srgbClr val="FFFFFF"/>
+                          </a:solidFill>
+                        </a:defRPr>
+                      </a:pPr>
+                    </a:p>
+                  </a:txBody>
+                  <a:tcPr>
+                    <a:solidFill>
+                      <a:srgbClr val="34495E"/>
+                    </a:solidFill>
+                  </a:tcPr>
+                </a:tc>
+                <a:tc>
+                  <a:txBody>
+                    <a:bodyPr/>
+                    <a:lstStyle/>
+                    <a:p>
+                      <a:pPr>
+                        <a:defRPr b="1" sz="1300">
+                          <a:solidFill>
+                            <a:srgbClr val="FFFFFF"/>
+                          </a:solidFill>
+                        </a:defRPr>
+                      </a:pPr>
+                      <a:r>
+                        <a:t>HashInsight</a:t>
+                      </a:r>
+                    </a:p>
+                  </a:txBody>
+                  <a:tcPr>
+                    <a:solidFill>
+                      <a:srgbClr val="34495E"/>
+                    </a:solidFill>
+                  </a:tcPr>
+                </a:tc>
+                <a:tc>
+                  <a:txBody>
+                    <a:bodyPr/>
+                    <a:lstStyle/>
+                    <a:p>
+                      <a:pPr>
+                        <a:defRPr b="1" sz="1300">
+                          <a:solidFill>
+                            <a:srgbClr val="FFFFFF"/>
+                          </a:solidFill>
+                        </a:defRPr>
+                      </a:pPr>
+                      <a:r>
+                        <a:t>Foreman</a:t>
+                      </a:r>
+                    </a:p>
+                  </a:txBody>
+                  <a:tcPr>
+                    <a:solidFill>
+                      <a:srgbClr val="34495E"/>
+                    </a:solidFill>
+                  </a:tcPr>
+                </a:tc>
+                <a:tc>
+                  <a:txBody>
+                    <a:bodyPr/>
+                    <a:lstStyle/>
+                    <a:p>
+                      <a:pPr>
+                        <a:defRPr b="1" sz="1300">
+                          <a:solidFill>
+                            <a:srgbClr val="FFFFFF"/>
+                          </a:solidFill>
+                        </a:defRPr>
+                      </a:pPr>
+                      <a:r>
+                        <a:t>NiceHash</a:t>
+                      </a:r>
+                    </a:p>
+                  </a:txBody>
+                  <a:tcPr>
+                    <a:solidFill>
+                      <a:srgbClr val="34495E"/>
+                    </a:solidFill>
+                  </a:tcPr>
+                </a:tc>
+              </a:tr>
+              <a:tr h="609600">
+                <a:tc>
+                  <a:txBody>
+                    <a:bodyPr/>
+                    <a:lstStyle/>
+                    <a:p>
+                      <a:pPr>
+                        <a:defRPr sz="1100"/>
+                      </a:pPr>
+                      <a:r>
+                        <a:t>Dual-Algorithm</a:t>
+                      </a:r>
+                    </a:p>
+                  </a:txBody>
+                  <a:tcPr/>
+                </a:tc>
+                <a:tc>
+                  <a:txBody>
+                    <a:bodyPr/>
+                    <a:lstStyle/>
+                    <a:p>
+                      <a:pPr>
+                        <a:defRPr sz="1100"/>
+                      </a:pPr>
+                      <a:r>
+                        <a:t>✓</a:t>
+                      </a:r>
+                    </a:p>
+                  </a:txBody>
+                  <a:tcPr/>
+                </a:tc>
+                <a:tc>
+                  <a:txBody>
+                    <a:bodyPr/>
+                    <a:lstStyle/>
+                    <a:p>
+                      <a:pPr>
+                        <a:defRPr sz="1100"/>
+                      </a:pPr>
+                      <a:r>
+                        <a:t>✗</a:t>
+                      </a:r>
+                    </a:p>
+                  </a:txBody>
+                  <a:tcPr/>
+                </a:tc>
+                <a:tc>
+                  <a:txBody>
+                    <a:bodyPr/>
+                    <a:lstStyle/>
+                    <a:p>
+                      <a:pPr>
+                        <a:defRPr sz="1100"/>
+                      </a:pPr>
+                      <a:r>
+                        <a:t>✗</a:t>
+                      </a:r>
+                    </a:p>
+                  </a:txBody>
+                  <a:tcPr/>
+                </a:tc>
+              </a:tr>
+              <a:tr h="609600">
+                <a:tc>
+                  <a:txBody>
+                    <a:bodyPr/>
+                    <a:lstStyle/>
+                    <a:p>
+                      <a:pPr>
+                        <a:defRPr sz="1100"/>
+                      </a:pPr>
+                      <a:r>
+                        <a:t>Batch 5000+</a:t>
+                      </a:r>
+                    </a:p>
+                  </a:txBody>
+                  <a:tcPr>
+                    <a:solidFill>
+                      <a:srgbClr val="ECF0F1"/>
+                    </a:solidFill>
+                  </a:tcPr>
+                </a:tc>
+                <a:tc>
+                  <a:txBody>
+                    <a:bodyPr/>
+                    <a:lstStyle/>
+                    <a:p>
+                      <a:pPr>
+                        <a:defRPr sz="1100"/>
+                      </a:pPr>
+                      <a:r>
+                        <a:t>✓</a:t>
+                      </a:r>
+                    </a:p>
+                  </a:txBody>
+                  <a:tcPr>
+                    <a:solidFill>
+                      <a:srgbClr val="ECF0F1"/>
+                    </a:solidFill>
+                  </a:tcPr>
+                </a:tc>
+                <a:tc>
+                  <a:txBody>
+                    <a:bodyPr/>
+                    <a:lstStyle/>
+                    <a:p>
+                      <a:pPr>
+                        <a:defRPr sz="1100"/>
+                      </a:pPr>
+                      <a:r>
+                        <a:t>500 max</a:t>
+                      </a:r>
+                    </a:p>
+                  </a:txBody>
+                  <a:tcPr>
+                    <a:solidFill>
+                      <a:srgbClr val="ECF0F1"/>
+                    </a:solidFill>
+                  </a:tcPr>
+                </a:tc>
+                <a:tc>
+                  <a:txBody>
+                    <a:bodyPr/>
+                    <a:lstStyle/>
+                    <a:p>
+                      <a:pPr>
+                        <a:defRPr sz="1100"/>
+                      </a:pPr>
+                      <a:r>
+                        <a:t>Single only</a:t>
+                      </a:r>
+                    </a:p>
+                  </a:txBody>
+                  <a:tcPr>
+                    <a:solidFill>
+                      <a:srgbClr val="ECF0F1"/>
+                    </a:solidFill>
+                  </a:tcPr>
+                </a:tc>
+              </a:tr>
+              <a:tr h="609600">
+                <a:tc>
+                  <a:txBody>
+                    <a:bodyPr/>
+                    <a:lstStyle/>
+                    <a:p>
+                      <a:pPr>
+                        <a:defRPr sz="1100"/>
+                      </a:pPr>
+                      <a:r>
+                        <a:t>Treasury Mgmt</a:t>
+                      </a:r>
+                    </a:p>
+                  </a:txBody>
+                  <a:tcPr/>
+                </a:tc>
+                <a:tc>
+                  <a:txBody>
+                    <a:bodyPr/>
+                    <a:lstStyle/>
+                    <a:p>
+                      <a:pPr>
+                        <a:defRPr sz="1100"/>
+                      </a:pPr>
+                      <a:r>
+                        <a:t>✓</a:t>
+                      </a:r>
+                    </a:p>
+                  </a:txBody>
+                  <a:tcPr/>
+                </a:tc>
+                <a:tc>
+                  <a:txBody>
+                    <a:bodyPr/>
+                    <a:lstStyle/>
+                    <a:p>
+                      <a:pPr>
+                        <a:defRPr sz="1100"/>
+                      </a:pPr>
+                      <a:r>
+                        <a:t>✗</a:t>
+                      </a:r>
+                    </a:p>
+                  </a:txBody>
+                  <a:tcPr/>
+                </a:tc>
+                <a:tc>
+                  <a:txBody>
+                    <a:bodyPr/>
+                    <a:lstStyle/>
+                    <a:p>
+                      <a:pPr>
+                        <a:defRPr sz="1100"/>
+                      </a:pPr>
+                      <a:r>
+                        <a:t>✗</a:t>
+                      </a:r>
+                    </a:p>
+                  </a:txBody>
+                  <a:tcPr/>
+                </a:tc>
+              </a:tr>
+              <a:tr h="609600">
+                <a:tc>
+                  <a:txBody>
+                    <a:bodyPr/>
+                    <a:lstStyle/>
+                    <a:p>
+                      <a:pPr>
+                        <a:defRPr sz="1100"/>
+                      </a:pPr>
+                      <a:r>
+                        <a:t>SOC 2 Ready</a:t>
+                      </a:r>
+                    </a:p>
+                  </a:txBody>
+                  <a:tcPr>
+                    <a:solidFill>
+                      <a:srgbClr val="ECF0F1"/>
+                    </a:solidFill>
+                  </a:tcPr>
+                </a:tc>
+                <a:tc>
+                  <a:txBody>
+                    <a:bodyPr/>
+                    <a:lstStyle/>
+                    <a:p>
+                      <a:pPr>
+                        <a:defRPr sz="1100"/>
+                      </a:pPr>
+                      <a:r>
+                        <a:t>✓</a:t>
+                      </a:r>
+                    </a:p>
+                  </a:txBody>
+                  <a:tcPr>
+                    <a:solidFill>
+                      <a:srgbClr val="ECF0F1"/>
+                    </a:solidFill>
+                  </a:tcPr>
+                </a:tc>
+                <a:tc>
+                  <a:txBody>
+                    <a:bodyPr/>
+                    <a:lstStyle/>
+                    <a:p>
+                      <a:pPr>
+                        <a:defRPr sz="1100"/>
+                      </a:pPr>
+                      <a:r>
+                        <a:t>✗</a:t>
+                      </a:r>
+                    </a:p>
+                  </a:txBody>
+                  <a:tcPr>
+                    <a:solidFill>
+                      <a:srgbClr val="ECF0F1"/>
+                    </a:solidFill>
+                  </a:tcPr>
+                </a:tc>
+                <a:tc>
+                  <a:txBody>
+                    <a:bodyPr/>
+                    <a:lstStyle/>
+                    <a:p>
+                      <a:pPr>
+                        <a:defRPr sz="1100"/>
+                      </a:pPr>
+                      <a:r>
+                        <a:t>✗</a:t>
+                      </a:r>
+                    </a:p>
+                  </a:txBody>
+                  <a:tcPr>
+                    <a:solidFill>
+                      <a:srgbClr val="ECF0F1"/>
+                    </a:solidFill>
+                  </a:tcPr>
+                </a:tc>
+              </a:tr>
+              <a:tr h="609600">
+                <a:tc>
+                  <a:txBody>
+                    <a:bodyPr/>
+                    <a:lstStyle/>
+                    <a:p>
+                      <a:pPr>
+                        <a:defRPr sz="1100"/>
+                      </a:pPr>
+                      <a:r>
+                        <a:t>Support</a:t>
+                      </a:r>
+                    </a:p>
+                  </a:txBody>
+                  <a:tcPr/>
+                </a:tc>
+                <a:tc>
+                  <a:txBody>
+                    <a:bodyPr/>
+                    <a:lstStyle/>
+                    <a:p>
+                      <a:pPr>
+                        <a:defRPr sz="1100"/>
+                      </a:pPr>
+                      <a:r>
+                        <a:t>24/7+CSM</a:t>
+                      </a:r>
+                    </a:p>
+                  </a:txBody>
+                  <a:tcPr/>
+                </a:tc>
+                <a:tc>
+                  <a:txBody>
+                    <a:bodyPr/>
+                    <a:lstStyle/>
+                    <a:p>
+                      <a:pPr>
+                        <a:defRPr sz="1100"/>
+                      </a:pPr>
+                      <a:r>
+                        <a:t>Email</a:t>
+                      </a:r>
+                    </a:p>
+                  </a:txBody>
+                  <a:tcPr/>
+                </a:tc>
+                <a:tc>
+                  <a:txBody>
+                    <a:bodyPr/>
+                    <a:lstStyle/>
+                    <a:p>
+                      <a:pPr>
+                        <a:defRPr sz="1100"/>
+                      </a:pPr>
+                      <a:r>
+                        <a:t>Forum</a:t>
+                      </a:r>
+                    </a:p>
+                  </a:txBody>
+                  <a:tcPr/>
+                </a:tc>
+              </a:tr>
+            </a:tbl>
+          </a:graphicData>
+        </a:graphic>
+      </p:graphicFrame>
+    </p:spTree>
+  </p:cSld>
+  <p:clrMapOvr>
+    <a:masterClrMapping/>
+  </p:clrMapOvr>
+</p:sld>
+</file>
+
+<file path=ppt/slides/slide7.xml><?xml version="1.0" encoding="utf-8"?>
+<p:sld xmlns:a="http://schemas.openxmlformats.org/drawingml/2006/main" xmlns:p="http://schemas.openxmlformats.org/presentationml/2006/main" xmlns:r="http://schemas.openxmlformats.org/officeDocument/2006/relationships">
+  <p:cSld>
+    <p:spTree>
+      <p:nvGrpSpPr>
+        <p:cNvPr id="1" name=""/>
+        <p:cNvGrpSpPr/>
+        <p:nvPr/>
+      </p:nvGrpSpPr>
+      <p:grpSpPr/>
+      <p:sp>
+        <p:nvSpPr>
+          <p:cNvPr id="2" name="TextBox 1"/>
+          <p:cNvSpPr txBox="1"/>
+          <p:nvPr/>
+        </p:nvSpPr>
+        <p:spPr>
+          <a:xfrm>
+            <a:off x="457200" y="457200"/>
+            <a:ext cx="8229600" cy="731520"/>
+          </a:xfrm>
+          <a:prstGeom prst="rect">
+            <a:avLst/>
+          </a:prstGeom>
+          <a:noFill/>
+        </p:spPr>
+        <p:txBody>
+          <a:bodyPr wrap="none">
+            <a:spAutoFit/>
+          </a:bodyPr>
+          <a:lstStyle/>
+          <a:p>
+            <a:pPr>
+              <a:defRPr sz="3600" b="1">
+                <a:solidFill>
+                  <a:srgbClr val="2C3E50"/>
+                </a:solidFill>
+              </a:defRPr>
+            </a:pPr>
+            <a:r>
+              <a:t>Customer Success: 100MW Farm</a:t>
             </a:r>
           </a:p>
         </p:txBody>
@@ -4462,7 +4970,7 @@
               <a:defRPr sz="1400"/>
             </a:pPr>
             <a:r>
-              <a:t>1. Industry's Only Dual-Algorithm Validation System</a:t>
+              <a:t>Before HashInsight:</a:t>
             </a:r>
           </a:p>
           <a:p>
@@ -4472,6 +4980,9 @@
               </a:spcBef>
               <a:defRPr sz="1400"/>
             </a:pPr>
+            <a:r>
+              <a:t>  Calculation: 2 hours/day</a:t>
+            </a:r>
           </a:p>
           <a:p>
             <a:pPr>
@@ -4481,7 +4992,7 @@
               <a:defRPr sz="1400"/>
             </a:pPr>
             <a:r>
-              <a:t>2. 9.8x Performance via Request Coalescing</a:t>
+              <a:t>  Manual errors: 12/month</a:t>
             </a:r>
           </a:p>
           <a:p>
@@ -4491,6 +5002,9 @@
               </a:spcBef>
               <a:defRPr sz="1400"/>
             </a:pPr>
+            <a:r>
+              <a:t>  Customer complaints: 100/month</a:t>
+            </a:r>
           </a:p>
           <a:p>
             <a:pPr>
@@ -4499,9 +5013,6 @@
               </a:spcBef>
               <a:defRPr sz="1400"/>
             </a:pPr>
-            <a:r>
-              <a:t>3. Professional-Grade Treasury Management</a:t>
-            </a:r>
           </a:p>
           <a:p>
             <a:pPr>
@@ -4510,6 +5021,9 @@
               </a:spcBef>
               <a:defRPr sz="1400"/>
             </a:pPr>
+            <a:r>
+              <a:t>After HashInsight:</a:t>
+            </a:r>
           </a:p>
           <a:p>
             <a:pPr>
@@ -4519,7 +5033,7 @@
               <a:defRPr sz="1400"/>
             </a:pPr>
             <a:r>
-              <a:t>4. 10 Intelligent Signal Aggregation Modules</a:t>
+              <a:t>  Calculation: 5 minutes (24x faster)</a:t>
             </a:r>
           </a:p>
           <a:p>
@@ -4529,6 +5043,9 @@
               </a:spcBef>
               <a:defRPr sz="1400"/>
             </a:pPr>
+            <a:r>
+              <a:t>  Manual errors: 0/month (100% eliminated)</a:t>
+            </a:r>
           </a:p>
           <a:p>
             <a:pPr>
@@ -4538,7 +5055,7 @@
               <a:defRPr sz="1400"/>
             </a:pPr>
             <a:r>
-              <a:t>5. Enterprise-Grade Security &amp; Compliance</a:t>
+              <a:t>  Customer complaints: 30/month (70% reduction)</a:t>
             </a:r>
           </a:p>
           <a:p>
@@ -4549,7 +5066,7 @@
               <a:defRPr sz="1400"/>
             </a:pPr>
             <a:r>
-              <a:t>   KMS encryption, mTLS auth, SOC 2 ready</a:t>
+              <a:t>  Power cost savings: $1.8M/year</a:t>
             </a:r>
           </a:p>
           <a:p>
@@ -4568,211 +5085,7 @@
               <a:defRPr sz="1400"/>
             </a:pPr>
             <a:r>
-              <a:t>6. Fully Page-Isolated Architecture</a:t>
-            </a:r>
-          </a:p>
-        </p:txBody>
-      </p:sp>
-    </p:spTree>
-  </p:cSld>
-  <p:clrMapOvr>
-    <a:masterClrMapping/>
-  </p:clrMapOvr>
-</p:sld>
-</file>
-
-<file path=ppt/slides/slide7.xml><?xml version="1.0" encoding="utf-8"?>
-<p:sld xmlns:a="http://schemas.openxmlformats.org/drawingml/2006/main" xmlns:p="http://schemas.openxmlformats.org/presentationml/2006/main" xmlns:r="http://schemas.openxmlformats.org/officeDocument/2006/relationships">
-  <p:cSld>
-    <p:spTree>
-      <p:nvGrpSpPr>
-        <p:cNvPr id="1" name=""/>
-        <p:cNvGrpSpPr/>
-        <p:nvPr/>
-      </p:nvGrpSpPr>
-      <p:grpSpPr/>
-      <p:sp>
-        <p:nvSpPr>
-          <p:cNvPr id="2" name="TextBox 1"/>
-          <p:cNvSpPr txBox="1"/>
-          <p:nvPr/>
-        </p:nvSpPr>
-        <p:spPr>
-          <a:xfrm>
-            <a:off x="457200" y="457200"/>
-            <a:ext cx="8229600" cy="731520"/>
-          </a:xfrm>
-          <a:prstGeom prst="rect">
-            <a:avLst/>
-          </a:prstGeom>
-          <a:noFill/>
-        </p:spPr>
-        <p:txBody>
-          <a:bodyPr wrap="none">
-            <a:spAutoFit/>
-          </a:bodyPr>
-          <a:lstStyle/>
-          <a:p>
-            <a:pPr>
-              <a:defRPr sz="3600" b="1">
-                <a:solidFill>
-                  <a:srgbClr val="2C3E50"/>
-                </a:solidFill>
-              </a:defRPr>
-            </a:pPr>
-            <a:r>
-              <a:t>Typical Use Cases</a:t>
-            </a:r>
-          </a:p>
-        </p:txBody>
-      </p:sp>
-      <p:sp>
-        <p:nvSpPr>
-          <p:cNvPr id="3" name="Rectangle 2"/>
-          <p:cNvSpPr/>
-          <p:nvPr/>
-        </p:nvSpPr>
-        <p:spPr>
-          <a:xfrm>
-            <a:off x="457200" y="1143000"/>
-            <a:ext cx="8229600" cy="45720"/>
-          </a:xfrm>
-          <a:prstGeom prst="rect">
-            <a:avLst/>
-          </a:prstGeom>
-          <a:solidFill>
-            <a:srgbClr val="F39C12"/>
-          </a:solidFill>
-          <a:ln>
-            <a:solidFill>
-              <a:srgbClr val="F39C12"/>
-            </a:solidFill>
-          </a:ln>
-        </p:spPr>
-        <p:style>
-          <a:lnRef idx="1">
-            <a:schemeClr val="accent1"/>
-          </a:lnRef>
-          <a:fillRef idx="3">
-            <a:schemeClr val="accent1"/>
-          </a:fillRef>
-          <a:effectRef idx="2">
-            <a:schemeClr val="accent1"/>
-          </a:effectRef>
-          <a:fontRef idx="minor">
-            <a:schemeClr val="lt1"/>
-          </a:fontRef>
-        </p:style>
-        <p:txBody>
-          <a:bodyPr rtlCol="0" anchor="ctr"/>
-          <a:lstStyle/>
-          <a:p>
-            <a:pPr algn="ctr"/>
-          </a:p>
-        </p:txBody>
-      </p:sp>
-      <p:sp>
-        <p:nvSpPr>
-          <p:cNvPr id="4" name="TextBox 3"/>
-          <p:cNvSpPr txBox="1"/>
-          <p:nvPr/>
-        </p:nvSpPr>
-        <p:spPr>
-          <a:xfrm>
-            <a:off x="457200" y="1463040"/>
-            <a:ext cx="8229600" cy="4114800"/>
-          </a:xfrm>
-          <a:prstGeom prst="rect">
-            <a:avLst/>
-          </a:prstGeom>
-          <a:noFill/>
-        </p:spPr>
-        <p:txBody>
-          <a:bodyPr wrap="square">
-            <a:spAutoFit/>
-          </a:bodyPr>
-          <a:lstStyle/>
-          <a:p/>
-          <a:p>
-            <a:pPr>
-              <a:spcBef>
-                <a:spcPts val="400"/>
-              </a:spcBef>
-              <a:defRPr sz="1400"/>
-            </a:pPr>
-            <a:r>
-              <a:t>Large Mining Farms</a:t>
-            </a:r>
-          </a:p>
-          <a:p>
-            <a:pPr>
-              <a:spcBef>
-                <a:spcPts val="400"/>
-              </a:spcBef>
-              <a:defRPr sz="1400"/>
-            </a:pPr>
-            <a:r>
-              <a:t>  • 15,000+ miners, 10x efficiency, 15-20% cost savings</a:t>
-            </a:r>
-          </a:p>
-          <a:p>
-            <a:pPr>
-              <a:spcBef>
-                <a:spcPts val="400"/>
-              </a:spcBef>
-              <a:defRPr sz="1400"/>
-            </a:pPr>
-          </a:p>
-          <a:p>
-            <a:pPr>
-              <a:spcBef>
-                <a:spcPts val="400"/>
-              </a:spcBef>
-              <a:defRPr sz="1400"/>
-            </a:pPr>
-            <a:r>
-              <a:t>Hosting Providers</a:t>
-            </a:r>
-          </a:p>
-          <a:p>
-            <a:pPr>
-              <a:spcBef>
-                <a:spcPts val="400"/>
-              </a:spcBef>
-              <a:defRPr sz="1400"/>
-            </a:pPr>
-            <a:r>
-              <a:t>  • 300+ clients, 40% trust increase, standardized service</a:t>
-            </a:r>
-          </a:p>
-          <a:p>
-            <a:pPr>
-              <a:spcBef>
-                <a:spcPts val="400"/>
-              </a:spcBef>
-              <a:defRPr sz="1400"/>
-            </a:pPr>
-          </a:p>
-          <a:p>
-            <a:pPr>
-              <a:spcBef>
-                <a:spcPts val="400"/>
-              </a:spcBef>
-              <a:defRPr sz="1400"/>
-            </a:pPr>
-            <a:r>
-              <a:t>Institutional Investors</a:t>
-            </a:r>
-          </a:p>
-          <a:p>
-            <a:pPr>
-              <a:spcBef>
-                <a:spcPts val="400"/>
-              </a:spcBef>
-              <a:defRPr sz="1400"/>
-            </a:pPr>
-            <a:r>
-              <a:t>  • ROI evaluation, BTC inventory, 10-15% better timing</a:t>
+              <a:t>ROI: 158x | Payback: 2.3 days</a:t>
             </a:r>
           </a:p>
         </p:txBody>
@@ -4825,7 +5138,7 @@
               </a:defRPr>
             </a:pPr>
             <a:r>
-              <a:t>Flexible Subscription Plans</a:t>
+              <a:t>Pricing Plans</a:t>
             </a:r>
           </a:p>
         </p:txBody>
@@ -4894,7 +5207,7 @@
                 <a:gridCol w="1920240"/>
                 <a:gridCol w="1920240"/>
               </a:tblGrid>
-              <a:tr h="731520">
+              <a:tr h="914400">
                 <a:tc>
                   <a:txBody>
                     <a:bodyPr/>
@@ -4977,7 +5290,7 @@
                         </a:defRPr>
                       </a:pPr>
                       <a:r>
-                        <a:t>Key Features</a:t>
+                        <a:t>ROI</a:t>
                       </a:r>
                     </a:p>
                   </a:txBody>
@@ -4988,7 +5301,7 @@
                   </a:tcPr>
                 </a:tc>
               </a:tr>
-              <a:tr h="731520">
+              <a:tr h="914400">
                 <a:tc>
                   <a:txBody>
                     <a:bodyPr/>
@@ -4998,7 +5311,7 @@
                         <a:defRPr sz="1100"/>
                       </a:pPr>
                       <a:r>
-                        <a:t>Free</a:t>
+                        <a:t>Professional</a:t>
                       </a:r>
                     </a:p>
                   </a:txBody>
@@ -5013,7 +5326,7 @@
                         <a:defRPr sz="1100"/>
                       </a:pPr>
                       <a:r>
-                        <a:t>$0/mo</a:t>
+                        <a:t>$199/mo</a:t>
                       </a:r>
                     </a:p>
                   </a:txBody>
@@ -5028,7 +5341,7 @@
                         <a:defRPr sz="1100"/>
                       </a:pPr>
                       <a:r>
-                        <a:t>Individual</a:t>
+                        <a:t>Small-medium</a:t>
                       </a:r>
                     </a:p>
                   </a:txBody>
@@ -5043,14 +5356,14 @@
                         <a:defRPr sz="1100"/>
                       </a:pPr>
                       <a:r>
-                        <a:t>Basic calculator</a:t>
+                        <a:t>15-20x</a:t>
                       </a:r>
                     </a:p>
                   </a:txBody>
                   <a:tcPr/>
                 </a:tc>
               </a:tr>
-              <a:tr h="731520">
+              <a:tr h="914400">
                 <a:tc>
                   <a:txBody>
                     <a:bodyPr/>
@@ -5060,7 +5373,7 @@
                         <a:defRPr sz="1100"/>
                       </a:pPr>
                       <a:r>
-                        <a:t>Professional</a:t>
+                        <a:t>Enterprise</a:t>
                       </a:r>
                     </a:p>
                   </a:txBody>
@@ -5079,7 +5392,7 @@
                         <a:defRPr sz="1100"/>
                       </a:pPr>
                       <a:r>
-                        <a:t>$199/mo</a:t>
+                        <a:t>$999/mo</a:t>
                       </a:r>
                     </a:p>
                   </a:txBody>
@@ -5098,7 +5411,7 @@
                         <a:defRPr sz="1100"/>
                       </a:pPr>
                       <a:r>
-                        <a:t>Small-medium</a:t>
+                        <a:t>Large institutions</a:t>
                       </a:r>
                     </a:p>
                   </a:txBody>
@@ -5117,7 +5430,7 @@
                         <a:defRPr sz="1100"/>
                       </a:pPr>
                       <a:r>
-                        <a:t>Batch, analytics, CRM</a:t>
+                        <a:t>50-100x</a:t>
                       </a:r>
                     </a:p>
                   </a:txBody>
@@ -5128,7 +5441,7 @@
                   </a:tcPr>
                 </a:tc>
               </a:tr>
-              <a:tr h="731520">
+              <a:tr h="914400">
                 <a:tc>
                   <a:txBody>
                     <a:bodyPr/>
@@ -5138,7 +5451,7 @@
                         <a:defRPr sz="1100"/>
                       </a:pPr>
                       <a:r>
-                        <a:t>Enterprise</a:t>
+                        <a:t>Custom</a:t>
                       </a:r>
                     </a:p>
                   </a:txBody>
@@ -5153,7 +5466,7 @@
                         <a:defRPr sz="1100"/>
                       </a:pPr>
                       <a:r>
-                        <a:t>$999/mo</a:t>
+                        <a:t>Custom</a:t>
                       </a:r>
                     </a:p>
                   </a:txBody>
@@ -5168,7 +5481,7 @@
                         <a:defRPr sz="1100"/>
                       </a:pPr>
                       <a:r>
-                        <a:t>Large institutions</a:t>
+                        <a:t>Ultra-large</a:t>
                       </a:r>
                     </a:p>
                   </a:txBody>
@@ -5183,89 +5496,11 @@
                         <a:defRPr sz="1100"/>
                       </a:pPr>
                       <a:r>
-                        <a:t>Full features, Treasury</a:t>
+                        <a:t>100-200x</a:t>
                       </a:r>
                     </a:p>
                   </a:txBody>
                   <a:tcPr/>
-                </a:tc>
-              </a:tr>
-              <a:tr h="731520">
-                <a:tc>
-                  <a:txBody>
-                    <a:bodyPr/>
-                    <a:lstStyle/>
-                    <a:p>
-                      <a:pPr>
-                        <a:defRPr sz="1100"/>
-                      </a:pPr>
-                      <a:r>
-                        <a:t>Custom</a:t>
-                      </a:r>
-                    </a:p>
-                  </a:txBody>
-                  <a:tcPr>
-                    <a:solidFill>
-                      <a:srgbClr val="ECF0F1"/>
-                    </a:solidFill>
-                  </a:tcPr>
-                </a:tc>
-                <a:tc>
-                  <a:txBody>
-                    <a:bodyPr/>
-                    <a:lstStyle/>
-                    <a:p>
-                      <a:pPr>
-                        <a:defRPr sz="1100"/>
-                      </a:pPr>
-                      <a:r>
-                        <a:t>Custom</a:t>
-                      </a:r>
-                    </a:p>
-                  </a:txBody>
-                  <a:tcPr>
-                    <a:solidFill>
-                      <a:srgbClr val="ECF0F1"/>
-                    </a:solidFill>
-                  </a:tcPr>
-                </a:tc>
-                <a:tc>
-                  <a:txBody>
-                    <a:bodyPr/>
-                    <a:lstStyle/>
-                    <a:p>
-                      <a:pPr>
-                        <a:defRPr sz="1100"/>
-                      </a:pPr>
-                      <a:r>
-                        <a:t>Ultra-large</a:t>
-                      </a:r>
-                    </a:p>
-                  </a:txBody>
-                  <a:tcPr>
-                    <a:solidFill>
-                      <a:srgbClr val="ECF0F1"/>
-                    </a:solidFill>
-                  </a:tcPr>
-                </a:tc>
-                <a:tc>
-                  <a:txBody>
-                    <a:bodyPr/>
-                    <a:lstStyle/>
-                    <a:p>
-                      <a:pPr>
-                        <a:defRPr sz="1100"/>
-                      </a:pPr>
-                      <a:r>
-                        <a:t>Private deployment</a:t>
-                      </a:r>
-                    </a:p>
-                  </a:txBody>
-                  <a:tcPr>
-                    <a:solidFill>
-                      <a:srgbClr val="ECF0F1"/>
-                    </a:solidFill>
-                  </a:tcPr>
                 </a:tc>
               </a:tr>
             </a:tbl>
@@ -5501,7 +5736,7 @@
               <a:defRPr sz="1400"/>
             </a:pPr>
             <a:r>
-              <a:t>  • 24/7 technical hotline, 1-hour response SLA</a:t>
+              <a:t>  24/7 hotline, 1-hour response SLA</a:t>
             </a:r>
           </a:p>
         </p:txBody>

</xml_diff>